<commit_message>
Presentation: test count 228 -> 252 (slides 13 and 15, speaker notes; PDF/PPTX re-exported from the deck source)
Co-Authored-By: Claude Opus 5.5 <noreply@anthropic.com>
</commit_message>
<xml_diff>
--- a/docs/presentation/Golden_Fighter_AI_presentation.pptx
+++ b/docs/presentation/Golden_Fighter_AI_presentation.pptx
@@ -796,7 +796,7 @@
           <a:lstStyle/>
           <a:p>
             <a:r>
-              <a:t>הלקח הגדול: עם סוכני AI, זה רץ לא אומר זה נכון. בריצות האמיתיות מצאתי ארבע טעויות: סוכן ייחס מספר לדוח הלא נכון; סוכן סירב לכתוב את חלוקת 80/20 כי אף כלי לא החזיר אותה; חשיבות הפיצ'רים הוצגה כאילו היא של ניסוי הדליפה; ובלבול בין קריאות API בתשלום לבין הפעלות כלים חינמיות. כל טעות כזו הפכה לבדיקה אוטומטית ולטסט, כך שהיא לא יכולה לחזור. בסוף הפרויקט יש 228 טסטים, וכולם רצים בלי מפתח API. (דקה)</a:t>
+              <a:t>הלקח הגדול: עם סוכני AI, זה רץ לא אומר זה נכון. בריצות האמיתיות מצאתי ארבע טעויות: סוכן ייחס מספר לדוח הלא נכון; סוכן סירב לכתוב את חלוקת 80/20 כי אף כלי לא החזיר אותה; חשיבות הפיצ'רים הוצגה כאילו היא של ניסוי הדליפה; ובלבול בין קריאות API בתשלום לבין הפעלות כלים חינמיות. כל טעות כזו הפכה לבדיקה אוטומטית ולטסט, כך שהיא לא יכולה לחזור. בסוף הפרויקט יש 252 טסטים, וכולם רצים בלי מפתח API. (דקה)</a:t>
             </a:r>
           </a:p>
         </p:txBody>
@@ -936,7 +936,7 @@
           <a:lstStyle/>
           <a:p>
             <a:r>
-              <a:t>לסיכום: בניתי לא עוד מודל, אלא תהליך שבו ההעברה בין הצוותים לא יכולה להשתבש בשקט. שני צוותים של סוכנים, חוזה נתונים אחד, ושער שאי אפשר לשכנע, ו-228 טסטים שמוודאים שכל זה עובד. תודה, אשמח לשאלות. (20 שניות)</a:t>
+              <a:t>לסיכום: בניתי לא עוד מודל, אלא תהליך שבו ההעברה בין הצוותים לא יכולה להשתבש בשקט. שני צוותים של סוכנים, חוזה נתונים אחד, ושער שאי אפשר לשכנע, ו-252 טסטים שמוודאים שכל זה עובד. תודה, אשמח לשאלות. (20 שניות)</a:t>
             </a:r>
           </a:p>
         </p:txBody>

</xml_diff>